<commit_message>
docs: rebuild sample-aware submission deck
</commit_message>
<xml_diff>
--- a/competition/2026-08-15/submission/agentfit-preliminary-draft.pptx
+++ b/competition/2026-08-15/submission/agentfit-preliminary-draft.pptx
@@ -8711,7 +8711,7 @@
                 </a:solidFill>
                 <a:latin typeface="Noto Sans CJK SC"/>
               </a:rPr>
-              <a:t>六层 ML 映射把“方案设计”变成可优化对象</a:t>
+              <a:t>七层 ML 映射把“方案设计”变成可优化对象</a:t>
             </a:r>
           </a:p>
         </p:txBody>
@@ -8863,7 +8863,7 @@
         <p:spPr>
           <a:xfrm>
             <a:off x="933602" y="2152497"/>
-            <a:ext cx="1155801" cy="160020"/>
+            <a:ext cx="1292047" cy="160020"/>
           </a:xfrm>
           <a:prstGeom prst="rect">
             <a:avLst/>
@@ -8895,7 +8895,7 @@
                 </a:solidFill>
                 <a:latin typeface="Noto Sans Mono CJK SC"/>
               </a:rPr>
-              <a:t>SIX-LAYER MAPPING</a:t>
+              <a:t>SEVEN-LAYER MAPPING</a:t>
             </a:r>
           </a:p>
         </p:txBody>
@@ -8908,377 +8908,369 @@
         </p:nvSpPr>
         <p:spPr>
           <a:xfrm>
-            <a:off x="933602" y="2514600"/>
-            <a:ext cx="4915814" cy="188366"/>
-          </a:xfrm>
-          <a:prstGeom prst="rect">
-            <a:avLst/>
-          </a:prstGeom>
-          <a:noFill/>
-        </p:spPr>
-        <p:txBody>
-          <a:bodyPr wrap="square" lIns="0" tIns="0" rIns="0" bIns="0">
-            <a:spAutoFit/>
-          </a:bodyPr>
-          <a:lstStyle/>
-          <a:p>
-            <a:pPr marL="0" indent="0" algn="l">
-              <a:lnSpc>
-                <a:spcPts val="1490"/>
-              </a:lnSpc>
-              <a:spcBef>
-                <a:spcPts val="0"/>
-              </a:spcBef>
-              <a:spcAft>
-                <a:spcPts val="0"/>
-              </a:spcAft>
-              <a:buNone/>
-            </a:pPr>
-            <a:r>
-              <a:rPr b="1" sz="1120">
+            <a:off x="933602" y="2419502"/>
+            <a:ext cx="4915814" cy="213969"/>
+          </a:xfrm>
+          <a:prstGeom prst="rect">
+            <a:avLst/>
+          </a:prstGeom>
+          <a:noFill/>
+        </p:spPr>
+        <p:txBody>
+          <a:bodyPr wrap="square" lIns="0" tIns="0" rIns="0" bIns="0">
+            <a:spAutoFit/>
+          </a:bodyPr>
+          <a:lstStyle/>
+          <a:p>
+            <a:pPr marL="0" indent="0" algn="l">
+              <a:lnSpc>
+                <a:spcPts val="1680"/>
+              </a:lnSpc>
+              <a:spcBef>
+                <a:spcPts val="0"/>
+              </a:spcBef>
+              <a:spcAft>
+                <a:spcPts val="0"/>
+              </a:spcAft>
+              <a:buNone/>
+            </a:pPr>
+            <a:r>
+              <a:rPr sz="1280">
                 <a:solidFill>
                   <a:srgbClr val="FFFFFF"/>
                 </a:solidFill>
                 <a:latin typeface="Noto Sans CJK SC"/>
               </a:rPr>
-              <a:t>L1 任务语义</a:t>
-            </a:r>
-            <a:r>
-              <a:rPr sz="1120">
+              <a:t>L1 样本语义 → 样本单位、边界、重放与标注契约</a:t>
+            </a:r>
+          </a:p>
+        </p:txBody>
+      </p:sp>
+      <p:sp>
+        <p:nvSpPr>
+          <p:cNvPr id="10" name="h2p-13-text-9"/>
+          <p:cNvSpPr txBox="1"/>
+          <p:nvPr/>
+        </p:nvSpPr>
+        <p:spPr>
+          <a:xfrm>
+            <a:off x="933602" y="2819095"/>
+            <a:ext cx="4915814" cy="213969"/>
+          </a:xfrm>
+          <a:prstGeom prst="rect">
+            <a:avLst/>
+          </a:prstGeom>
+          <a:noFill/>
+        </p:spPr>
+        <p:txBody>
+          <a:bodyPr wrap="square" lIns="0" tIns="0" rIns="0" bIns="0">
+            <a:spAutoFit/>
+          </a:bodyPr>
+          <a:lstStyle/>
+          <a:p>
+            <a:pPr marL="0" indent="0" algn="l">
+              <a:lnSpc>
+                <a:spcPts val="1680"/>
+              </a:lnSpc>
+              <a:spcBef>
+                <a:spcPts val="0"/>
+              </a:spcBef>
+              <a:spcAft>
+                <a:spcPts val="0"/>
+              </a:spcAft>
+              <a:buNone/>
+            </a:pPr>
+            <a:r>
+              <a:rPr sz="1280">
                 <a:solidFill>
                   <a:srgbClr val="FFFFFF"/>
                 </a:solidFill>
                 <a:latin typeface="Noto Sans CJK SC"/>
               </a:rPr>
-              <a:t> → 学习问题、输入输出、指标与权衡</a:t>
-            </a:r>
-          </a:p>
-        </p:txBody>
-      </p:sp>
-      <p:sp>
-        <p:nvSpPr>
-          <p:cNvPr id="10" name="h2p-13-text-9"/>
-          <p:cNvSpPr txBox="1"/>
-          <p:nvPr/>
-        </p:nvSpPr>
-        <p:spPr>
-          <a:xfrm>
-            <a:off x="933602" y="2991002"/>
-            <a:ext cx="4915814" cy="188366"/>
-          </a:xfrm>
-          <a:prstGeom prst="rect">
-            <a:avLst/>
-          </a:prstGeom>
-          <a:noFill/>
-        </p:spPr>
-        <p:txBody>
-          <a:bodyPr wrap="square" lIns="0" tIns="0" rIns="0" bIns="0">
-            <a:spAutoFit/>
-          </a:bodyPr>
-          <a:lstStyle/>
-          <a:p>
-            <a:pPr marL="0" indent="0" algn="l">
-              <a:lnSpc>
-                <a:spcPts val="1490"/>
-              </a:lnSpc>
-              <a:spcBef>
-                <a:spcPts val="0"/>
-              </a:spcBef>
-              <a:spcAft>
-                <a:spcPts val="0"/>
-              </a:spcAft>
-              <a:buNone/>
-            </a:pPr>
-            <a:r>
-              <a:rPr b="1" sz="1120">
+              <a:t>L2 任务语义 → 分布、输出、指标、损失与权衡</a:t>
+            </a:r>
+          </a:p>
+        </p:txBody>
+      </p:sp>
+      <p:sp>
+        <p:nvSpPr>
+          <p:cNvPr id="11" name="h2p-13-text-10"/>
+          <p:cNvSpPr txBox="1"/>
+          <p:nvPr/>
+        </p:nvSpPr>
+        <p:spPr>
+          <a:xfrm>
+            <a:off x="933602" y="3219602"/>
+            <a:ext cx="4915814" cy="213969"/>
+          </a:xfrm>
+          <a:prstGeom prst="rect">
+            <a:avLst/>
+          </a:prstGeom>
+          <a:noFill/>
+        </p:spPr>
+        <p:txBody>
+          <a:bodyPr wrap="square" lIns="0" tIns="0" rIns="0" bIns="0">
+            <a:spAutoFit/>
+          </a:bodyPr>
+          <a:lstStyle/>
+          <a:p>
+            <a:pPr marL="0" indent="0" algn="l">
+              <a:lnSpc>
+                <a:spcPts val="1680"/>
+              </a:lnSpc>
+              <a:spcBef>
+                <a:spcPts val="0"/>
+              </a:spcBef>
+              <a:spcAft>
+                <a:spcPts val="0"/>
+              </a:spcAft>
+              <a:buNone/>
+            </a:pPr>
+            <a:r>
+              <a:rPr sz="1280">
                 <a:solidFill>
                   <a:srgbClr val="FFFFFF"/>
                 </a:solidFill>
                 <a:latin typeface="Noto Sans CJK SC"/>
               </a:rPr>
-              <a:t>L2 能力语义</a:t>
-            </a:r>
-            <a:r>
-              <a:rPr sz="1120">
+              <a:t>L3 能力语义 → 算子集、契约、权限与适用域</a:t>
+            </a:r>
+          </a:p>
+        </p:txBody>
+      </p:sp>
+      <p:sp>
+        <p:nvSpPr>
+          <p:cNvPr id="12" name="h2p-13-text-11"/>
+          <p:cNvSpPr txBox="1"/>
+          <p:nvPr/>
+        </p:nvSpPr>
+        <p:spPr>
+          <a:xfrm>
+            <a:off x="933602" y="3619195"/>
+            <a:ext cx="4915814" cy="213969"/>
+          </a:xfrm>
+          <a:prstGeom prst="rect">
+            <a:avLst/>
+          </a:prstGeom>
+          <a:noFill/>
+        </p:spPr>
+        <p:txBody>
+          <a:bodyPr wrap="square" lIns="0" tIns="0" rIns="0" bIns="0">
+            <a:spAutoFit/>
+          </a:bodyPr>
+          <a:lstStyle/>
+          <a:p>
+            <a:pPr marL="0" indent="0" algn="l">
+              <a:lnSpc>
+                <a:spcPts val="1680"/>
+              </a:lnSpc>
+              <a:spcBef>
+                <a:spcPts val="0"/>
+              </a:spcBef>
+              <a:spcAft>
+                <a:spcPts val="0"/>
+              </a:spcAft>
+              <a:buNone/>
+            </a:pPr>
+            <a:r>
+              <a:rPr sz="1280">
                 <a:solidFill>
                   <a:srgbClr val="FFFFFF"/>
                 </a:solidFill>
                 <a:latin typeface="Noto Sans CJK SC"/>
               </a:rPr>
-              <a:t> → 算子集、契约、权限与适用域</a:t>
-            </a:r>
-          </a:p>
-        </p:txBody>
-      </p:sp>
-      <p:sp>
-        <p:nvSpPr>
-          <p:cNvPr id="11" name="h2p-13-text-10"/>
-          <p:cNvSpPr txBox="1"/>
-          <p:nvPr/>
-        </p:nvSpPr>
-        <p:spPr>
-          <a:xfrm>
-            <a:off x="933602" y="3467404"/>
-            <a:ext cx="4915814" cy="188366"/>
-          </a:xfrm>
-          <a:prstGeom prst="rect">
-            <a:avLst/>
-          </a:prstGeom>
-          <a:noFill/>
-        </p:spPr>
-        <p:txBody>
-          <a:bodyPr wrap="square" lIns="0" tIns="0" rIns="0" bIns="0">
-            <a:spAutoFit/>
-          </a:bodyPr>
-          <a:lstStyle/>
-          <a:p>
-            <a:pPr marL="0" indent="0" algn="l">
-              <a:lnSpc>
-                <a:spcPts val="1490"/>
-              </a:lnSpc>
-              <a:spcBef>
-                <a:spcPts val="0"/>
-              </a:spcBef>
-              <a:spcAft>
-                <a:spcPts val="0"/>
-              </a:spcAft>
-              <a:buNone/>
-            </a:pPr>
-            <a:r>
-              <a:rPr b="1" sz="1120">
+              <a:t>L4 候选表示 → 结构、分区、参数与共享范围</a:t>
+            </a:r>
+          </a:p>
+        </p:txBody>
+      </p:sp>
+      <p:sp>
+        <p:nvSpPr>
+          <p:cNvPr id="13" name="h2p-13-text-12"/>
+          <p:cNvSpPr txBox="1"/>
+          <p:nvPr/>
+        </p:nvSpPr>
+        <p:spPr>
+          <a:xfrm>
+            <a:off x="933602" y="4019702"/>
+            <a:ext cx="4915814" cy="213969"/>
+          </a:xfrm>
+          <a:prstGeom prst="rect">
+            <a:avLst/>
+          </a:prstGeom>
+          <a:noFill/>
+        </p:spPr>
+        <p:txBody>
+          <a:bodyPr wrap="square" lIns="0" tIns="0" rIns="0" bIns="0">
+            <a:spAutoFit/>
+          </a:bodyPr>
+          <a:lstStyle/>
+          <a:p>
+            <a:pPr marL="0" indent="0" algn="l">
+              <a:lnSpc>
+                <a:spcPts val="1680"/>
+              </a:lnSpc>
+              <a:spcBef>
+                <a:spcPts val="0"/>
+              </a:spcBef>
+              <a:spcAft>
+                <a:spcPts val="0"/>
+              </a:spcAft>
+              <a:buNone/>
+            </a:pPr>
+            <a:r>
+              <a:rPr sz="1280">
                 <a:solidFill>
                   <a:srgbClr val="FFFFFF"/>
                 </a:solidFill>
                 <a:latin typeface="Noto Sans CJK SC"/>
               </a:rPr>
-              <a:t>L3 候选表示</a:t>
-            </a:r>
-            <a:r>
-              <a:rPr sz="1120">
+              <a:t>L5 内循环 → adaptation samples 上优化局部参数</a:t>
+            </a:r>
+          </a:p>
+        </p:txBody>
+      </p:sp>
+      <p:sp>
+        <p:nvSpPr>
+          <p:cNvPr id="14" name="h2p-13-text-13"/>
+          <p:cNvSpPr txBox="1"/>
+          <p:nvPr/>
+        </p:nvSpPr>
+        <p:spPr>
+          <a:xfrm>
+            <a:off x="933602" y="4419295"/>
+            <a:ext cx="4915814" cy="213969"/>
+          </a:xfrm>
+          <a:prstGeom prst="rect">
+            <a:avLst/>
+          </a:prstGeom>
+          <a:noFill/>
+        </p:spPr>
+        <p:txBody>
+          <a:bodyPr wrap="square" lIns="0" tIns="0" rIns="0" bIns="0">
+            <a:spAutoFit/>
+          </a:bodyPr>
+          <a:lstStyle/>
+          <a:p>
+            <a:pPr marL="0" indent="0" algn="l">
+              <a:lnSpc>
+                <a:spcPts val="1680"/>
+              </a:lnSpc>
+              <a:spcBef>
+                <a:spcPts val="0"/>
+              </a:spcBef>
+              <a:spcAft>
+                <a:spcPts val="0"/>
+              </a:spcAft>
+              <a:buNone/>
+            </a:pPr>
+            <a:r>
+              <a:rPr sz="1280">
                 <a:solidFill>
                   <a:srgbClr val="FFFFFF"/>
                 </a:solidFill>
                 <a:latin typeface="Noto Sans CJK SC"/>
               </a:rPr>
-              <a:t> → 结构、分区、参数与共享范围</a:t>
-            </a:r>
-          </a:p>
-        </p:txBody>
-      </p:sp>
-      <p:sp>
-        <p:nvSpPr>
-          <p:cNvPr id="12" name="h2p-13-text-11"/>
-          <p:cNvSpPr txBox="1"/>
-          <p:nvPr/>
-        </p:nvSpPr>
-        <p:spPr>
-          <a:xfrm>
-            <a:off x="933602" y="3942892"/>
-            <a:ext cx="4915814" cy="188366"/>
-          </a:xfrm>
-          <a:prstGeom prst="rect">
-            <a:avLst/>
-          </a:prstGeom>
-          <a:noFill/>
-        </p:spPr>
-        <p:txBody>
-          <a:bodyPr wrap="square" lIns="0" tIns="0" rIns="0" bIns="0">
-            <a:spAutoFit/>
-          </a:bodyPr>
-          <a:lstStyle/>
-          <a:p>
-            <a:pPr marL="0" indent="0" algn="l">
-              <a:lnSpc>
-                <a:spcPts val="1490"/>
-              </a:lnSpc>
-              <a:spcBef>
-                <a:spcPts val="0"/>
-              </a:spcBef>
-              <a:spcAft>
-                <a:spcPts val="0"/>
-              </a:spcAft>
-              <a:buNone/>
-            </a:pPr>
-            <a:r>
-              <a:rPr b="1" sz="1120">
+              <a:t>L6 外循环 → validation samples 上比较候选架构</a:t>
+            </a:r>
+          </a:p>
+        </p:txBody>
+      </p:sp>
+      <p:sp>
+        <p:nvSpPr>
+          <p:cNvPr id="15" name="h2p-13-text-14"/>
+          <p:cNvSpPr txBox="1"/>
+          <p:nvPr/>
+        </p:nvSpPr>
+        <p:spPr>
+          <a:xfrm>
+            <a:off x="933602" y="4819802"/>
+            <a:ext cx="4915814" cy="213969"/>
+          </a:xfrm>
+          <a:prstGeom prst="rect">
+            <a:avLst/>
+          </a:prstGeom>
+          <a:noFill/>
+        </p:spPr>
+        <p:txBody>
+          <a:bodyPr wrap="square" lIns="0" tIns="0" rIns="0" bIns="0">
+            <a:spAutoFit/>
+          </a:bodyPr>
+          <a:lstStyle/>
+          <a:p>
+            <a:pPr marL="0" indent="0" algn="l">
+              <a:lnSpc>
+                <a:spcPts val="1680"/>
+              </a:lnSpc>
+              <a:spcBef>
+                <a:spcPts val="0"/>
+              </a:spcBef>
+              <a:spcAft>
+                <a:spcPts val="0"/>
+              </a:spcAft>
+              <a:buNone/>
+            </a:pPr>
+            <a:r>
+              <a:rPr sz="1280">
                 <a:solidFill>
                   <a:srgbClr val="FFFFFF"/>
                 </a:solidFill>
                 <a:latin typeface="Noto Sans CJK SC"/>
               </a:rPr>
-              <a:t>L4 内循环</a:t>
-            </a:r>
-            <a:r>
-              <a:rPr sz="1120">
-                <a:solidFill>
-                  <a:srgbClr val="FFFFFF"/>
+              <a:t>L7 跨项目学习 → 未见项目验证后更新搜索先验</a:t>
+            </a:r>
+          </a:p>
+        </p:txBody>
+      </p:sp>
+      <p:sp>
+        <p:nvSpPr>
+          <p:cNvPr id="16" name="h2p-13-text-15"/>
+          <p:cNvSpPr txBox="1"/>
+          <p:nvPr/>
+        </p:nvSpPr>
+        <p:spPr>
+          <a:xfrm>
+            <a:off x="933602" y="5296204"/>
+            <a:ext cx="4915814" cy="168249"/>
+          </a:xfrm>
+          <a:prstGeom prst="rect">
+            <a:avLst/>
+          </a:prstGeom>
+          <a:noFill/>
+        </p:spPr>
+        <p:txBody>
+          <a:bodyPr wrap="square" lIns="0" tIns="0" rIns="0" bIns="0">
+            <a:spAutoFit/>
+          </a:bodyPr>
+          <a:lstStyle/>
+          <a:p>
+            <a:pPr marL="0" indent="0" algn="l">
+              <a:lnSpc>
+                <a:spcPts val="1320"/>
+              </a:lnSpc>
+              <a:spcBef>
+                <a:spcPts val="0"/>
+              </a:spcBef>
+              <a:spcAft>
+                <a:spcPts val="0"/>
+              </a:spcAft>
+              <a:buNone/>
+            </a:pPr>
+            <a:r>
+              <a:rPr sz="1050">
+                <a:solidFill>
+                  <a:srgbClr val="D6A43B"/>
                 </a:solidFill>
                 <a:latin typeface="Noto Sans CJK SC"/>
               </a:rPr>
-              <a:t> → 固定结构内优化 Prompt / 阈值 / 配置</a:t>
-            </a:r>
-          </a:p>
-        </p:txBody>
-      </p:sp>
-      <p:sp>
-        <p:nvSpPr>
-          <p:cNvPr id="13" name="h2p-13-text-12"/>
-          <p:cNvSpPr txBox="1"/>
-          <p:nvPr/>
-        </p:nvSpPr>
-        <p:spPr>
-          <a:xfrm>
-            <a:off x="933602" y="4419295"/>
-            <a:ext cx="4915814" cy="188366"/>
-          </a:xfrm>
-          <a:prstGeom prst="rect">
-            <a:avLst/>
-          </a:prstGeom>
-          <a:noFill/>
-        </p:spPr>
-        <p:txBody>
-          <a:bodyPr wrap="square" lIns="0" tIns="0" rIns="0" bIns="0">
-            <a:spAutoFit/>
-          </a:bodyPr>
-          <a:lstStyle/>
-          <a:p>
-            <a:pPr marL="0" indent="0" algn="l">
-              <a:lnSpc>
-                <a:spcPts val="1490"/>
-              </a:lnSpc>
-              <a:spcBef>
-                <a:spcPts val="0"/>
-              </a:spcBef>
-              <a:spcAft>
-                <a:spcPts val="0"/>
-              </a:spcAft>
-              <a:buNone/>
-            </a:pPr>
-            <a:r>
-              <a:rPr b="1" sz="1120">
-                <a:solidFill>
-                  <a:srgbClr val="FFFFFF"/>
-                </a:solidFill>
-                <a:latin typeface="Noto Sans CJK SC"/>
-              </a:rPr>
-              <a:t>L5 外循环</a:t>
-            </a:r>
-            <a:r>
-              <a:rPr sz="1120">
-                <a:solidFill>
-                  <a:srgbClr val="FFFFFF"/>
-                </a:solidFill>
-                <a:latin typeface="Noto Sans CJK SC"/>
-              </a:rPr>
-              <a:t> → Agentize、拆分、合并与连边搜索</a:t>
-            </a:r>
-          </a:p>
-        </p:txBody>
-      </p:sp>
-      <p:sp>
-        <p:nvSpPr>
-          <p:cNvPr id="14" name="h2p-13-text-13"/>
-          <p:cNvSpPr txBox="1"/>
-          <p:nvPr/>
-        </p:nvSpPr>
-        <p:spPr>
-          <a:xfrm>
-            <a:off x="933602" y="4895697"/>
-            <a:ext cx="4915814" cy="188366"/>
-          </a:xfrm>
-          <a:prstGeom prst="rect">
-            <a:avLst/>
-          </a:prstGeom>
-          <a:noFill/>
-        </p:spPr>
-        <p:txBody>
-          <a:bodyPr wrap="square" lIns="0" tIns="0" rIns="0" bIns="0">
-            <a:spAutoFit/>
-          </a:bodyPr>
-          <a:lstStyle/>
-          <a:p>
-            <a:pPr marL="0" indent="0" algn="l">
-              <a:lnSpc>
-                <a:spcPts val="1490"/>
-              </a:lnSpc>
-              <a:spcBef>
-                <a:spcPts val="0"/>
-              </a:spcBef>
-              <a:spcAft>
-                <a:spcPts val="0"/>
-              </a:spcAft>
-              <a:buNone/>
-            </a:pPr>
-            <a:r>
-              <a:rPr b="1" sz="1120">
-                <a:solidFill>
-                  <a:srgbClr val="FFFFFF"/>
-                </a:solidFill>
-                <a:latin typeface="Noto Sans CJK SC"/>
-              </a:rPr>
-              <a:t>L6 跨项目学习</a:t>
-            </a:r>
-            <a:r>
-              <a:rPr sz="1120">
-                <a:solidFill>
-                  <a:srgbClr val="FFFFFF"/>
-                </a:solidFill>
-                <a:latin typeface="Noto Sans CJK SC"/>
-              </a:rPr>
-              <a:t> → 经未见项目验证后更新搜索先验</a:t>
-            </a:r>
-          </a:p>
-        </p:txBody>
-      </p:sp>
-      <p:sp>
-        <p:nvSpPr>
-          <p:cNvPr id="15" name="h2p-13-text-14"/>
-          <p:cNvSpPr txBox="1"/>
-          <p:nvPr/>
-        </p:nvSpPr>
-        <p:spPr>
-          <a:xfrm>
-            <a:off x="933602" y="5391302"/>
-            <a:ext cx="4915814" cy="168249"/>
-          </a:xfrm>
-          <a:prstGeom prst="rect">
-            <a:avLst/>
-          </a:prstGeom>
-          <a:noFill/>
-        </p:spPr>
-        <p:txBody>
-          <a:bodyPr wrap="square" lIns="0" tIns="0" rIns="0" bIns="0">
-            <a:spAutoFit/>
-          </a:bodyPr>
-          <a:lstStyle/>
-          <a:p>
-            <a:pPr marL="0" indent="0" algn="l">
-              <a:lnSpc>
-                <a:spcPts val="1320"/>
-              </a:lnSpc>
-              <a:spcBef>
-                <a:spcPts val="0"/>
-              </a:spcBef>
-              <a:spcAft>
-                <a:spcPts val="0"/>
-              </a:spcAft>
-              <a:buNone/>
-            </a:pPr>
-            <a:r>
-              <a:rPr sz="1050">
-                <a:solidFill>
-                  <a:srgbClr val="D6A43B"/>
-                </a:solidFill>
-                <a:latin typeface="Noto Sans CJK SC"/>
-              </a:rPr>
-              <a:t>L6 是未来方向：单项目沉淀不能证明跨项目学习。</a:t>
-            </a:r>
-          </a:p>
-        </p:txBody>
-      </p:sp>
-      <p:sp>
-        <p:nvSpPr>
-          <p:cNvPr id="16" name="h2p-13-box-15"/>
+              <a:t>L7 是未来方向：单项目样本优化不能证明跨项目学习。</a:t>
+            </a:r>
+          </a:p>
+        </p:txBody>
+      </p:sp>
+      <p:sp>
+        <p:nvSpPr>
+          <p:cNvPr id="17" name="h2p-13-box-16"/>
           <p:cNvSpPr/>
           <p:nvPr/>
         </p:nvSpPr>
@@ -9326,7 +9318,7 @@
       </p:sp>
       <p:sp>
         <p:nvSpPr>
-          <p:cNvPr id="17" name="h2p-13-text-16"/>
+          <p:cNvPr id="18" name="h2p-13-text-17"/>
           <p:cNvSpPr txBox="1"/>
           <p:nvPr/>
         </p:nvSpPr>
@@ -9372,7 +9364,7 @@
       </p:sp>
       <p:sp>
         <p:nvSpPr>
-          <p:cNvPr id="18" name="h2p-13-text-17"/>
+          <p:cNvPr id="19" name="h2p-13-text-18"/>
           <p:cNvSpPr txBox="1"/>
           <p:nvPr/>
         </p:nvSpPr>
@@ -9418,7 +9410,7 @@
       </p:sp>
       <p:sp>
         <p:nvSpPr>
-          <p:cNvPr id="19" name="h2p-13-text-18"/>
+          <p:cNvPr id="20" name="h2p-13-text-19"/>
           <p:cNvSpPr txBox="1"/>
           <p:nvPr/>
         </p:nvSpPr>
@@ -9487,7 +9479,7 @@
       </p:sp>
       <p:sp>
         <p:nvSpPr>
-          <p:cNvPr id="20" name="h2p-13-box-19"/>
+          <p:cNvPr id="21" name="h2p-13-box-20"/>
           <p:cNvSpPr/>
           <p:nvPr/>
         </p:nvSpPr>
@@ -9535,7 +9527,7 @@
       </p:sp>
       <p:sp>
         <p:nvSpPr>
-          <p:cNvPr id="21" name="h2p-13-text-20"/>
+          <p:cNvPr id="22" name="h2p-13-text-21"/>
           <p:cNvSpPr txBox="1"/>
           <p:nvPr/>
         </p:nvSpPr>
@@ -9581,7 +9573,7 @@
       </p:sp>
       <p:sp>
         <p:nvSpPr>
-          <p:cNvPr id="22" name="h2p-13-text-21"/>
+          <p:cNvPr id="23" name="h2p-13-text-22"/>
           <p:cNvSpPr txBox="1"/>
           <p:nvPr/>
         </p:nvSpPr>
@@ -9627,14 +9619,14 @@
       </p:sp>
       <p:sp>
         <p:nvSpPr>
-          <p:cNvPr id="23" name="h2p-13-text-22"/>
+          <p:cNvPr id="24" name="h2p-13-text-23"/>
           <p:cNvSpPr txBox="1"/>
           <p:nvPr/>
         </p:nvSpPr>
         <p:spPr>
           <a:xfrm>
             <a:off x="6648602" y="5048402"/>
-            <a:ext cx="1923897" cy="566013"/>
+            <a:ext cx="1923897" cy="376732"/>
           </a:xfrm>
           <a:prstGeom prst="rect">
             <a:avLst/>
@@ -9666,60 +9658,14 @@
                 </a:solidFill>
                 <a:latin typeface="Noto Sans CJK SC"/>
               </a:rPr>
-              <a:t>固定 G / Π</a:t>
-            </a:r>
-          </a:p>
-          <a:p>
-            <a:pPr marL="0" indent="0" algn="l">
-              <a:lnSpc>
-                <a:spcPts val="1490"/>
-              </a:lnSpc>
-              <a:spcBef>
-                <a:spcPts val="0"/>
-              </a:spcBef>
-              <a:spcAft>
-                <a:spcPts val="0"/>
-              </a:spcAft>
-              <a:buNone/>
-            </a:pPr>
-            <a:r>
-              <a:rPr sz="1120">
-                <a:solidFill>
-                  <a:srgbClr val="53697C"/>
-                </a:solidFill>
-                <a:latin typeface="Noto Sans CJK SC"/>
-              </a:rPr>
-              <a:t>更新 θ / ρ</a:t>
-            </a:r>
-          </a:p>
-          <a:p>
-            <a:pPr marL="0" indent="0" algn="l">
-              <a:lnSpc>
-                <a:spcPts val="1490"/>
-              </a:lnSpc>
-              <a:spcBef>
-                <a:spcPts val="0"/>
-              </a:spcBef>
-              <a:spcAft>
-                <a:spcPts val="0"/>
-              </a:spcAft>
-              <a:buNone/>
-            </a:pPr>
-            <a:r>
-              <a:rPr sz="1120">
-                <a:solidFill>
-                  <a:srgbClr val="53697C"/>
-                </a:solidFill>
-                <a:latin typeface="Noto Sans CJK SC"/>
-              </a:rPr>
-              <a:t>看验证集表现</a:t>
-            </a:r>
-          </a:p>
-        </p:txBody>
-      </p:sp>
-      <p:sp>
-        <p:nvSpPr>
-          <p:cNvPr id="24" name="h2p-13-box-23"/>
+              <a:t>固定 G / Π；更新 θ / ρ；遍历 adaptation samples</a:t>
+            </a:r>
+          </a:p>
+        </p:txBody>
+      </p:sp>
+      <p:sp>
+        <p:nvSpPr>
+          <p:cNvPr id="25" name="h2p-13-box-24"/>
           <p:cNvSpPr/>
           <p:nvPr/>
         </p:nvSpPr>
@@ -9767,7 +9713,7 @@
       </p:sp>
       <p:sp>
         <p:nvSpPr>
-          <p:cNvPr id="25" name="h2p-13-text-24"/>
+          <p:cNvPr id="26" name="h2p-13-text-25"/>
           <p:cNvSpPr txBox="1"/>
           <p:nvPr/>
         </p:nvSpPr>
@@ -9813,7 +9759,7 @@
       </p:sp>
       <p:sp>
         <p:nvSpPr>
-          <p:cNvPr id="26" name="h2p-13-text-25"/>
+          <p:cNvPr id="27" name="h2p-13-text-26"/>
           <p:cNvSpPr txBox="1"/>
           <p:nvPr/>
         </p:nvSpPr>
@@ -9859,14 +9805,14 @@
       </p:sp>
       <p:sp>
         <p:nvSpPr>
-          <p:cNvPr id="27" name="h2p-13-text-26"/>
+          <p:cNvPr id="28" name="h2p-13-text-27"/>
           <p:cNvSpPr txBox="1"/>
           <p:nvPr/>
         </p:nvSpPr>
         <p:spPr>
           <a:xfrm>
             <a:off x="9296704" y="5048402"/>
-            <a:ext cx="2001621" cy="566013"/>
+            <a:ext cx="2001621" cy="376732"/>
           </a:xfrm>
           <a:prstGeom prst="rect">
             <a:avLst/>
@@ -9898,67 +9844,21 @@
                 </a:solidFill>
                 <a:latin typeface="Noto Sans CJK SC"/>
               </a:rPr>
-              <a:t>更新 G / Π</a:t>
-            </a:r>
-          </a:p>
-          <a:p>
-            <a:pPr marL="0" indent="0" algn="l">
-              <a:lnSpc>
-                <a:spcPts val="1490"/>
-              </a:lnSpc>
-              <a:spcBef>
-                <a:spcPts val="0"/>
-              </a:spcBef>
-              <a:spcAft>
-                <a:spcPts val="0"/>
-              </a:spcAft>
-              <a:buNone/>
-            </a:pPr>
-            <a:r>
-              <a:rPr sz="1120">
-                <a:solidFill>
-                  <a:srgbClr val="53697C"/>
-                </a:solidFill>
-                <a:latin typeface="Noto Sans CJK SC"/>
-              </a:rPr>
-              <a:t>比较复杂度与收益</a:t>
-            </a:r>
-          </a:p>
-          <a:p>
-            <a:pPr marL="0" indent="0" algn="l">
-              <a:lnSpc>
-                <a:spcPts val="1490"/>
-              </a:lnSpc>
-              <a:spcBef>
-                <a:spcPts val="0"/>
-              </a:spcBef>
-              <a:spcAft>
-                <a:spcPts val="0"/>
-              </a:spcAft>
-              <a:buNone/>
-            </a:pPr>
-            <a:r>
-              <a:rPr sz="1120">
-                <a:solidFill>
-                  <a:srgbClr val="53697C"/>
-                </a:solidFill>
-                <a:latin typeface="Noto Sans CJK SC"/>
-              </a:rPr>
-              <a:t>保留 Pareto 候选</a:t>
-            </a:r>
-          </a:p>
-        </p:txBody>
-      </p:sp>
-      <p:sp>
-        <p:nvSpPr>
-          <p:cNvPr id="28" name="h2p-13-text-27"/>
+              <a:t>更新 G / Π；比较 validation samples；保留 Pareto 候选</a:t>
+            </a:r>
+          </a:p>
+        </p:txBody>
+      </p:sp>
+      <p:sp>
+        <p:nvSpPr>
+          <p:cNvPr id="29" name="h2p-13-text-28"/>
           <p:cNvSpPr txBox="1"/>
           <p:nvPr/>
         </p:nvSpPr>
         <p:spPr>
           <a:xfrm>
             <a:off x="685800" y="6543446"/>
-            <a:ext cx="2350922" cy="105156"/>
+            <a:ext cx="2671876" cy="105156"/>
           </a:xfrm>
           <a:prstGeom prst="rect">
             <a:avLst/>
@@ -9990,14 +9890,14 @@
                 </a:solidFill>
                 <a:latin typeface="Noto Sans Mono CJK SC"/>
               </a:rPr>
-              <a:t>AGENTFIT · 任务语义 × 能力语义 × 架构搜索</a:t>
-            </a:r>
-          </a:p>
-        </p:txBody>
-      </p:sp>
-      <p:sp>
-        <p:nvSpPr>
-          <p:cNvPr id="29" name="h2p-13-text-28"/>
+              <a:t>AGENTFIT · SAMPLE × TASK × CAPABILITY × SEARCH</a:t>
+            </a:r>
+          </a:p>
+        </p:txBody>
+      </p:sp>
+      <p:sp>
+        <p:nvSpPr>
+          <p:cNvPr id="30" name="h2p-13-text-29"/>
           <p:cNvSpPr txBox="1"/>
           <p:nvPr/>
         </p:nvSpPr>
@@ -19614,30 +19514,7 @@
                 </a:solidFill>
                 <a:latin typeface="Noto Sans CJK SC"/>
               </a:rPr>
-              <a:t>把材料变成任务语义：</a:t>
-            </a:r>
-          </a:p>
-          <a:p>
-            <a:pPr marL="0" indent="0" algn="l">
-              <a:lnSpc>
-                <a:spcPts val="1920"/>
-              </a:lnSpc>
-              <a:spcBef>
-                <a:spcPts val="0"/>
-              </a:spcBef>
-              <a:spcAft>
-                <a:spcPts val="0"/>
-              </a:spcAft>
-              <a:buNone/>
-            </a:pPr>
-            <a:r>
-              <a:rPr sz="1350">
-                <a:solidFill>
-                  <a:srgbClr val="C6D3DD"/>
-                </a:solidFill>
-                <a:latin typeface="Noto Sans CJK SC"/>
-              </a:rPr>
-              <a:t>输入、输出、指标、预算、风险与 Human 边界。</a:t>
+              <a:t>先定义可重放样本，再编译任务语义：样本单位、输入、输出、指标与 Human 边界。</a:t>
             </a:r>
           </a:p>
         </p:txBody>
@@ -19731,7 +19608,7 @@
                 </a:solidFill>
                 <a:latin typeface="Noto Sans Mono CJK SC"/>
               </a:rPr>
-              <a:t>产物：任务说明书</a:t>
+              <a:t>产物：样本契约 + 任务说明书</a:t>
             </a:r>
           </a:p>
         </p:txBody>
@@ -20312,7 +20189,7 @@
                 </a:solidFill>
                 <a:latin typeface="Noto Sans CJK SC"/>
               </a:rPr>
-              <a:t>让不同候选在同一输入、预算、指标、安全线下公平赛跑。</a:t>
+              <a:t>让不同候选在同一冻结样本集、预算、指标和安全线下公平赛跑。</a:t>
             </a:r>
           </a:p>
         </p:txBody>
@@ -23030,7 +22907,7 @@
                 </a:solidFill>
                 <a:latin typeface="Noto Sans CJK SC"/>
               </a:rPr>
-              <a:t>候选共享同一套试卷；复杂度本身也是成本。</a:t>
+              <a:t>候选共享同一冻结样本集；复杂度本身也是成本。</a:t>
             </a:r>
           </a:p>
         </p:txBody>
@@ -23182,7 +23059,7 @@
         <p:spPr>
           <a:xfrm>
             <a:off x="933602" y="2723997"/>
-            <a:ext cx="932688" cy="269748"/>
+            <a:ext cx="1632204" cy="269748"/>
           </a:xfrm>
           <a:prstGeom prst="rect">
             <a:avLst/>
@@ -23214,7 +23091,7 @@
                 </a:solidFill>
                 <a:latin typeface="Noto Sans CJK SC"/>
               </a:rPr>
-              <a:t>同一试卷</a:t>
+              <a:t>同一冻结样本集</a:t>
             </a:r>
           </a:p>
         </p:txBody>
@@ -23260,7 +23137,7 @@
                 </a:solidFill>
                 <a:latin typeface="Noto Sans CJK SC"/>
               </a:rPr>
-              <a:t>相同输入</a:t>
+              <a:t>相同 TaskSample</a:t>
             </a:r>
           </a:p>
           <a:p>
@@ -25364,7 +25241,7 @@
         <p:spPr>
           <a:xfrm>
             <a:off x="2915107" y="3962095"/>
-            <a:ext cx="1806854" cy="357530"/>
+            <a:ext cx="2040026" cy="357530"/>
           </a:xfrm>
           <a:prstGeom prst="rect">
             <a:avLst/>
@@ -25396,7 +25273,7 @@
                 </a:solidFill>
                 <a:latin typeface="Noto Sans CJK SC"/>
               </a:rPr>
-              <a:t>编译任务语义</a:t>
+              <a:t>定义样本与任务</a:t>
             </a:r>
           </a:p>
           <a:p>
@@ -25419,7 +25296,7 @@
                 </a:solidFill>
                 <a:latin typeface="Noto Sans CJK SC"/>
               </a:rPr>
-              <a:t>产物：任务说明书</a:t>
+              <a:t>产物：样本契约 + 任务说明书</a:t>
             </a:r>
           </a:p>
         </p:txBody>
@@ -25874,7 +25751,7 @@
         <p:spPr>
           <a:xfrm>
             <a:off x="7371892" y="3962095"/>
-            <a:ext cx="1806854" cy="357530"/>
+            <a:ext cx="2040026" cy="357530"/>
           </a:xfrm>
           <a:prstGeom prst="rect">
             <a:avLst/>
@@ -25906,7 +25783,7 @@
                 </a:solidFill>
                 <a:latin typeface="Noto Sans CJK SC"/>
               </a:rPr>
-              <a:t>执行公平试验</a:t>
+              <a:t>按 TaskSample 执行</a:t>
             </a:r>
           </a:p>
           <a:p>
@@ -25929,7 +25806,7 @@
                 </a:solidFill>
                 <a:latin typeface="Noto Sans CJK SC"/>
               </a:rPr>
-              <a:t>产物：执行轨迹</a:t>
+              <a:t>产物：Episode + Trace</a:t>
             </a:r>
           </a:p>
         </p:txBody>
@@ -26418,7 +26295,7 @@
                 </a:solidFill>
                 <a:latin typeface="Noto Sans CJK SC"/>
               </a:rPr>
-              <a:t>同一项目档案 · 每次交接有产物 · 每次决策有 Trace · 审计后回到交付官</a:t>
+              <a:t>同一项目档案 · 每个样本可重放 · 每次执行有 Episode · 每次决策有 Trace</a:t>
             </a:r>
           </a:p>
         </p:txBody>

</xml_diff>

<commit_message>
fix: align sample lifecycle and deck validation
</commit_message>
<xml_diff>
--- a/competition/2026-08-15/submission/agentfit-preliminary-draft.pptx
+++ b/competition/2026-08-15/submission/agentfit-preliminary-draft.pptx
@@ -19238,7 +19238,7 @@
                 </a:solidFill>
                 <a:latin typeface="Noto Sans CJK SC"/>
               </a:rPr>
-              <a:t>AgentFit 先量体，再裁衣，最后试穿</a:t>
+              <a:t>AgentFit 先定义样本，再编译任务和方案</a:t>
             </a:r>
           </a:p>
         </p:txBody>
@@ -22907,7 +22907,7 @@
                 </a:solidFill>
                 <a:latin typeface="Noto Sans CJK SC"/>
               </a:rPr>
-              <a:t>候选共享同一冻结样本集；复杂度本身也是成本。</a:t>
+              <a:t>候选共享同一冻结 SampleSetManifest；复杂度本身也是成本。</a:t>
             </a:r>
           </a:p>
         </p:txBody>
@@ -23059,7 +23059,7 @@
         <p:spPr>
           <a:xfrm>
             <a:off x="933602" y="2723997"/>
-            <a:ext cx="1632204" cy="269748"/>
+            <a:ext cx="1399032" cy="269748"/>
           </a:xfrm>
           <a:prstGeom prst="rect">
             <a:avLst/>
@@ -23091,7 +23091,7 @@
                 </a:solidFill>
                 <a:latin typeface="Noto Sans CJK SC"/>
               </a:rPr>
-              <a:t>同一冻结样本集</a:t>
+              <a:t>冻结样本边界</a:t>
             </a:r>
           </a:p>
         </p:txBody>
@@ -23105,56 +23105,56 @@
         <p:spPr>
           <a:xfrm>
             <a:off x="933602" y="3161995"/>
-            <a:ext cx="1729130" cy="972921"/>
-          </a:xfrm>
-          <a:prstGeom prst="rect">
-            <a:avLst/>
-          </a:prstGeom>
-          <a:noFill/>
-        </p:spPr>
-        <p:txBody>
-          <a:bodyPr wrap="square" lIns="0" tIns="0" rIns="0" bIns="0">
-            <a:spAutoFit/>
-          </a:bodyPr>
-          <a:lstStyle/>
-          <a:p>
-            <a:pPr marL="0" indent="0" algn="l">
-              <a:lnSpc>
-                <a:spcPts val="1920"/>
-              </a:lnSpc>
-              <a:spcBef>
-                <a:spcPts val="0"/>
-              </a:spcBef>
-              <a:spcAft>
-                <a:spcPts val="0"/>
-              </a:spcAft>
-              <a:buNone/>
-            </a:pPr>
-            <a:r>
-              <a:rPr sz="1350">
+            <a:ext cx="1729130" cy="865936"/>
+          </a:xfrm>
+          <a:prstGeom prst="rect">
+            <a:avLst/>
+          </a:prstGeom>
+          <a:noFill/>
+        </p:spPr>
+        <p:txBody>
+          <a:bodyPr wrap="square" lIns="0" tIns="0" rIns="0" bIns="0">
+            <a:spAutoFit/>
+          </a:bodyPr>
+          <a:lstStyle/>
+          <a:p>
+            <a:pPr marL="0" indent="0" algn="l">
+              <a:lnSpc>
+                <a:spcPts val="1700"/>
+              </a:lnSpc>
+              <a:spcBef>
+                <a:spcPts val="0"/>
+              </a:spcBef>
+              <a:spcAft>
+                <a:spcPts val="0"/>
+              </a:spcAft>
+              <a:buNone/>
+            </a:pPr>
+            <a:r>
+              <a:rPr sz="1200">
                 <a:solidFill>
                   <a:srgbClr val="C6D3DD"/>
                 </a:solidFill>
                 <a:latin typeface="Noto Sans CJK SC"/>
               </a:rPr>
-              <a:t>相同 TaskSample</a:t>
-            </a:r>
-          </a:p>
-          <a:p>
-            <a:pPr marL="0" indent="0" algn="l">
-              <a:lnSpc>
-                <a:spcPts val="1920"/>
-              </a:lnSpc>
-              <a:spcBef>
-                <a:spcPts val="0"/>
-              </a:spcBef>
-              <a:spcAft>
-                <a:spcPts val="0"/>
-              </a:spcAft>
-              <a:buNone/>
-            </a:pPr>
-            <a:r>
-              <a:rPr sz="1350">
+              <a:t>同一版本化 TaskSample</a:t>
+            </a:r>
+          </a:p>
+          <a:p>
+            <a:pPr marL="0" indent="0" algn="l">
+              <a:lnSpc>
+                <a:spcPts val="1700"/>
+              </a:lnSpc>
+              <a:spcBef>
+                <a:spcPts val="0"/>
+              </a:spcBef>
+              <a:spcAft>
+                <a:spcPts val="0"/>
+              </a:spcAft>
+              <a:buNone/>
+            </a:pPr>
+            <a:r>
+              <a:rPr sz="1200">
                 <a:solidFill>
                   <a:srgbClr val="C6D3DD"/>
                 </a:solidFill>
@@ -23166,18 +23166,18 @@
           <a:p>
             <a:pPr marL="0" indent="0" algn="l">
               <a:lnSpc>
-                <a:spcPts val="1920"/>
-              </a:lnSpc>
-              <a:spcBef>
-                <a:spcPts val="0"/>
-              </a:spcBef>
-              <a:spcAft>
-                <a:spcPts val="0"/>
-              </a:spcAft>
-              <a:buNone/>
-            </a:pPr>
-            <a:r>
-              <a:rPr sz="1350">
+                <a:spcPts val="1700"/>
+              </a:lnSpc>
+              <a:spcBef>
+                <a:spcPts val="0"/>
+              </a:spcBef>
+              <a:spcAft>
+                <a:spcPts val="0"/>
+              </a:spcAft>
+              <a:buNone/>
+            </a:pPr>
+            <a:r>
+              <a:rPr sz="1200">
                 <a:solidFill>
                   <a:srgbClr val="C6D3DD"/>
                 </a:solidFill>
@@ -23189,18 +23189,18 @@
           <a:p>
             <a:pPr marL="0" indent="0" algn="l">
               <a:lnSpc>
-                <a:spcPts val="1920"/>
-              </a:lnSpc>
-              <a:spcBef>
-                <a:spcPts val="0"/>
-              </a:spcBef>
-              <a:spcAft>
-                <a:spcPts val="0"/>
-              </a:spcAft>
-              <a:buNone/>
-            </a:pPr>
-            <a:r>
-              <a:rPr sz="1350">
+                <a:spcPts val="1700"/>
+              </a:lnSpc>
+              <a:spcBef>
+                <a:spcPts val="0"/>
+              </a:spcBef>
+              <a:spcAft>
+                <a:spcPts val="0"/>
+              </a:spcAft>
+              <a:buNone/>
+            </a:pPr>
+            <a:r>
+              <a:rPr sz="1200">
                 <a:solidFill>
                   <a:srgbClr val="C6D3DD"/>
                 </a:solidFill>
@@ -26038,7 +26038,7 @@
                 </a:solidFill>
                 <a:latin typeface="Noto Sans CJK SC"/>
               </a:rPr>
-              <a:t>独立审计证据</a:t>
+              <a:t>冻结后独占 holdout</a:t>
             </a:r>
           </a:p>
           <a:p>
@@ -26061,7 +26061,7 @@
                 </a:solidFill>
                 <a:latin typeface="Noto Sans CJK SC"/>
               </a:rPr>
-              <a:t>产物：决策账本</a:t>
+              <a:t>产物：审计结论</a:t>
             </a:r>
           </a:p>
         </p:txBody>
@@ -26120,8 +26120,8 @@
         </p:nvSpPr>
         <p:spPr>
           <a:xfrm>
-            <a:off x="4038904" y="2190902"/>
-            <a:ext cx="4114800" cy="513892"/>
+            <a:off x="3276295" y="2190902"/>
+            <a:ext cx="5639104" cy="513892"/>
           </a:xfrm>
           <a:prstGeom prst="roundRect">
             <a:avLst>
@@ -26168,8 +26168,8 @@
         </p:nvSpPr>
         <p:spPr>
           <a:xfrm>
-            <a:off x="4230928" y="2324404"/>
-            <a:ext cx="3730752" cy="243230"/>
+            <a:off x="3453688" y="2342692"/>
+            <a:ext cx="5285232" cy="216712"/>
           </a:xfrm>
           <a:prstGeom prst="rect">
             <a:avLst/>
@@ -26184,24 +26184,24 @@
           <a:p>
             <a:pPr marL="0" indent="0" algn="ctr">
               <a:lnSpc>
-                <a:spcPts val="1920"/>
-              </a:lnSpc>
-              <a:spcBef>
-                <a:spcPts val="0"/>
-              </a:spcBef>
-              <a:spcAft>
-                <a:spcPts val="0"/>
-              </a:spcAft>
-              <a:buNone/>
-            </a:pPr>
-            <a:r>
-              <a:rPr b="1" sz="1350">
+                <a:spcPts val="1700"/>
+              </a:lnSpc>
+              <a:spcBef>
+                <a:spcPts val="0"/>
+              </a:spcBef>
+              <a:spcAft>
+                <a:spcPts val="0"/>
+              </a:spcAft>
+              <a:buNone/>
+            </a:pPr>
+            <a:r>
+              <a:rPr b="1" sz="1200">
                 <a:solidFill>
                   <a:srgbClr val="A5781C"/>
                 </a:solidFill>
                 <a:latin typeface="Noto Sans CJK SC"/>
               </a:rPr>
-              <a:t>HUMAN GATE · 批准任务、预算与高风险动作</a:t>
+              <a:t>HUMAN GATES · 候选前冻结 Sample/Task · 候选后批准 TrialSpec</a:t>
             </a:r>
           </a:p>
         </p:txBody>
@@ -26295,7 +26295,7 @@
                 </a:solidFill>
                 <a:latin typeface="Noto Sans CJK SC"/>
               </a:rPr>
-              <a:t>同一项目档案 · 每个样本可重放 · 每次执行有 Episode · 每次决策有 Trace</a:t>
+              <a:t>候选冻结后，仅 GovernanceAuditor 消费 sealed-holdout 结果</a:t>
             </a:r>
           </a:p>
         </p:txBody>

</xml_diff>